<commit_message>
Update URL in presentation
</commit_message>
<xml_diff>
--- a/material/intro-street/presentation-beginner.pptx
+++ b/material/intro-street/presentation-beginner.pptx
@@ -5322,19 +5322,11 @@
               <a:rPr lang="en-US" sz="3000" dirty="0">
                 <a:hlinkClick r:id="rId3"/>
               </a:rPr>
-              <a:t>https://git-pages.topdesk.com/</a:t>
-            </a:r>
-            <a:endParaRPr lang="nl-NL" sz="3000" dirty="0">
-              <a:hlinkClick r:id="rId3"/>
-            </a:endParaRPr>
-          </a:p>
-          <a:p>
-            <a:pPr algn="ctr"/>
-            <a:r>
-              <a:rPr lang="en-US" sz="3000" dirty="0">
-                <a:hlinkClick r:id="rId3"/>
-              </a:rPr>
-              <a:t>database-guild/beginner-database-workshop/</a:t>
+              <a:t>https://topdesk.github.io/database-detective/</a:t>
+            </a:r>
+            <a:r>
+              <a:rPr lang="en-US" sz="3000" dirty="0"/>
+              <a:t> </a:t>
             </a:r>
             <a:endParaRPr lang="nl-NL" sz="3000" dirty="0">
               <a:ea typeface="Calibri Light"/>

</xml_diff>